<commit_message>
Jal Rekha and District GIS  - new docs
Jal Rekha and District GIS  - new docs
</commit_message>
<xml_diff>
--- a/District_GIS_Parakh_CMMI_L5_Artifacts/District GIS Parakh Artefacts/indore inspection forms/Inspection_Management_System_Implementation (1).pptx
+++ b/District_GIS_Parakh_CMMI_L5_Artifacts/District GIS Parakh Artefacts/indore inspection forms/Inspection_Management_System_Implementation (1).pptx
@@ -1944,9 +1944,8 @@
                 <a:ea typeface="Cambria" pitchFamily="34" charset="-122"/>
                 <a:cs typeface="Cambria" pitchFamily="34" charset="-120"/>
               </a:rPr>
-              <a:t>Division-Level Review &amp; Commissioner Dashboard</a:t>
-            </a:r>
-            <a:endParaRPr lang="en-US" sz="3000" dirty="0"/>
+              <a:t>Division-Level Review &amp; Commissioner Dashboard (Now Completed)</a:t>
+            </a:r>
           </a:p>
         </p:txBody>
       </p:sp>
@@ -2688,7 +2687,18 @@
                 <a:ea typeface="Cambria" pitchFamily="34" charset="-122"/>
                 <a:cs typeface="Cambria" pitchFamily="34" charset="-120"/>
               </a:rPr>
-              <a:t>SOP Requirement → What's Built</a:t>
+              <a:t>SOP Requirement → What's Built ( </a:t>
+            </a:r>
+            <a:r>
+              <a:rPr lang="en-US" sz="3000" b="1">
+                <a:solidFill>
+                  <a:srgbClr val="1E2761"/>
+                </a:solidFill>
+                <a:latin typeface="Cambria" pitchFamily="34" charset="0"/>
+                <a:ea typeface="Cambria" pitchFamily="34" charset="-122"/>
+                <a:cs typeface="Cambria" pitchFamily="34" charset="-120"/>
+              </a:rPr>
+              <a:t>are completed )</a:t>
             </a:r>
             <a:endParaRPr lang="en-US" sz="3000" dirty="0"/>
           </a:p>
@@ -5211,43 +5221,52 @@
           <a:bodyPr wrap="square" rtlCol="0" anchor="ctr"/>
           <a:lstStyle/>
           <a:p>
+            <a:pPr algn="ctr">
+              <a:lnSpc>
+                <a:spcPts val="1600"/>
+              </a:lnSpc>
+            </a:pPr>
+            <a:r>
+              <a:rPr lang="en-US" sz="1350" b="1" dirty="0">
+                <a:solidFill>
+                  <a:srgbClr val="1E2761"/>
+                </a:solidFill>
+                <a:latin typeface="Calibri" pitchFamily="34" charset="0"/>
+                <a:ea typeface="Calibri" pitchFamily="34" charset="-122"/>
+                <a:cs typeface="Calibri" pitchFamily="34" charset="-120"/>
+              </a:rPr>
+              <a:t>4) Action to be taken by Reporting officer belongs to that department in that district   &amp; </a:t>
+            </a:r>
+            <a:br>
+              <a:rPr lang="en-US" sz="1350" b="1" dirty="0">
+                <a:solidFill>
+                  <a:srgbClr val="1E2761"/>
+                </a:solidFill>
+                <a:latin typeface="Calibri" pitchFamily="34" charset="0"/>
+                <a:ea typeface="Calibri" pitchFamily="34" charset="-122"/>
+                <a:cs typeface="Calibri" pitchFamily="34" charset="-120"/>
+              </a:rPr>
+            </a:br>
+            <a:r>
+              <a:rPr lang="en-US" sz="1350" b="1" dirty="0">
+                <a:solidFill>
+                  <a:srgbClr val="1E2761"/>
+                </a:solidFill>
+                <a:latin typeface="Calibri" pitchFamily="34" charset="0"/>
+                <a:ea typeface="Calibri" pitchFamily="34" charset="-122"/>
+                <a:cs typeface="Calibri" pitchFamily="34" charset="-120"/>
+              </a:rPr>
+              <a:t>5) Review by collectorate (Nodal) commissioner</a:t>
+            </a:r>
+            <a:endParaRPr lang="en-US" sz="1350" dirty="0"/>
+          </a:p>
+          <a:p>
             <a:pPr marL="0" indent="0" algn="ctr">
               <a:lnSpc>
                 <a:spcPts val="1600"/>
               </a:lnSpc>
               <a:buNone/>
             </a:pPr>
-            <a:r>
-              <a:rPr lang="en-US" sz="1350" b="1" dirty="0">
-                <a:solidFill>
-                  <a:srgbClr val="1E2761"/>
-                </a:solidFill>
-                <a:latin typeface="Calibri" pitchFamily="34" charset="0"/>
-                <a:ea typeface="Calibri" pitchFamily="34" charset="-122"/>
-                <a:cs typeface="Calibri" pitchFamily="34" charset="-120"/>
-              </a:rPr>
-              <a:t>Review &amp;</a:t>
-            </a:r>
-            <a:endParaRPr lang="en-US" sz="1350" dirty="0"/>
-          </a:p>
-          <a:p>
-            <a:pPr marL="0" indent="0" algn="ctr">
-              <a:lnSpc>
-                <a:spcPts val="1600"/>
-              </a:lnSpc>
-              <a:buNone/>
-            </a:pPr>
-            <a:r>
-              <a:rPr lang="en-US" sz="1350" b="1" dirty="0">
-                <a:solidFill>
-                  <a:srgbClr val="1E2761"/>
-                </a:solidFill>
-                <a:latin typeface="Calibri" pitchFamily="34" charset="0"/>
-                <a:ea typeface="Calibri" pitchFamily="34" charset="-122"/>
-                <a:cs typeface="Calibri" pitchFamily="34" charset="-120"/>
-              </a:rPr>
-              <a:t>Action</a:t>
-            </a:r>
             <a:endParaRPr lang="en-US" sz="1350" dirty="0"/>
           </a:p>
         </p:txBody>
@@ -5383,7 +5402,7 @@
           <a:bodyPr/>
           <a:lstStyle/>
           <a:p>
-            <a:endParaRPr lang="en-IN"/>
+            <a:endParaRPr lang="en-IN" dirty="0"/>
           </a:p>
         </p:txBody>
       </p:sp>
@@ -5480,17 +5499,6 @@
               </a:lnSpc>
               <a:buNone/>
             </a:pPr>
-            <a:r>
-              <a:rPr lang="en-US" sz="1350" b="1" dirty="0">
-                <a:solidFill>
-                  <a:srgbClr val="1E2761"/>
-                </a:solidFill>
-                <a:latin typeface="Calibri" pitchFamily="34" charset="0"/>
-                <a:ea typeface="Calibri" pitchFamily="34" charset="-122"/>
-                <a:cs typeface="Calibri" pitchFamily="34" charset="-120"/>
-              </a:rPr>
-              <a:t>Closure &amp;</a:t>
-            </a:r>
             <a:endParaRPr lang="en-US" sz="1350" dirty="0"/>
           </a:p>
           <a:p>
@@ -5551,7 +5559,7 @@
                 <a:ea typeface="Calibri" pitchFamily="34" charset="-122"/>
                 <a:cs typeface="Calibri" pitchFamily="34" charset="-120"/>
               </a:rPr>
-              <a:t>Inspection closed; Commissioner</a:t>
+              <a:t>Inspection monitoring ; Commissioner</a:t>
             </a:r>
             <a:endParaRPr lang="en-US" sz="1050" dirty="0"/>
           </a:p>
@@ -6411,36 +6419,6 @@
           </a:p>
         </p:txBody>
       </p:sp>
-      <p:pic>
-        <p:nvPicPr>
-          <p:cNvPr id="22" name="Picture 21" descr="The image contains a list of Hindi words and phrases, which are titles for various types of checklists, such as agriculture, forest, and education.&#10;&#10;AI-generated content may be incorrect.">
-            <a:extLst>
-              <a:ext uri="{FF2B5EF4-FFF2-40B4-BE49-F238E27FC236}">
-                <a16:creationId xmlns:a16="http://schemas.microsoft.com/office/drawing/2014/main" id="{3F2412AF-CE4D-15CE-D730-AF365BB20EA1}"/>
-              </a:ext>
-            </a:extLst>
-          </p:cNvPr>
-          <p:cNvPicPr>
-            <a:picLocks noChangeAspect="1"/>
-          </p:cNvPicPr>
-          <p:nvPr/>
-        </p:nvPicPr>
-        <p:blipFill>
-          <a:blip r:embed="rId4"/>
-          <a:stretch>
-            <a:fillRect/>
-          </a:stretch>
-        </p:blipFill>
-        <p:spPr>
-          <a:xfrm>
-            <a:off x="6156222" y="1371600"/>
-            <a:ext cx="2946381" cy="4735508"/>
-          </a:xfrm>
-          <a:prstGeom prst="rect">
-            <a:avLst/>
-          </a:prstGeom>
-        </p:spPr>
-      </p:pic>
     </p:spTree>
   </p:cSld>
   <p:clrMapOvr>

</xml_diff>